<commit_message>
mark both authors in deliverables
</commit_message>
<xml_diff>
--- a/docs/entregables/Presentacion_Chompas_Mabel.pptx
+++ b/docs/entregables/Presentacion_Chompas_Mabel.pptx
@@ -3420,13 +3420,13 @@
           <a:p>
             <a:pPr algn="l"/>
             <a:r>
-              <a:rPr sz="1200" b="0">
+              <a:rPr sz="1200">
                 <a:solidFill>
                   <a:srgbClr val="E2E8F0"/>
                 </a:solidFill>
                 <a:latin typeface="Arial"/>
               </a:rPr>
-              <a:t>Presentado por: ANGULO GONZALES Diego Gabriel</a:t>
+              <a:t>Integrantes:</a:t>
             </a:r>
           </a:p>
         </p:txBody>
@@ -3440,7 +3440,7 @@
         <p:spPr>
           <a:xfrm>
             <a:off x="667512" y="5230368"/>
-            <a:ext cx="4754880" cy="274320"/>
+            <a:ext cx="4754880" cy="502920"/>
           </a:xfrm>
           <a:prstGeom prst="rect">
             <a:avLst/>
@@ -3455,13 +3455,14 @@
           <a:p>
             <a:pPr algn="l"/>
             <a:r>
-              <a:rPr sz="1200" b="0">
+              <a:rPr sz="1200">
                 <a:solidFill>
                   <a:srgbClr val="E2E8F0"/>
                 </a:solidFill>
                 <a:latin typeface="Arial"/>
               </a:rPr>
-              <a:t>Colaborador: CRUZ SALAZAR Jorge Luis</a:t>
+              <a:t>ANGULO GONZALES Diego Gabriel
+CRUZ SALAZAR Jorge Luis</a:t>
             </a:r>
           </a:p>
         </p:txBody>

</xml_diff>